<commit_message>
parsed learning_log to produce md version
</commit_message>
<xml_diff>
--- a/reference/IGCSE Physics Learning Log.pptx
+++ b/reference/IGCSE Physics Learning Log.pptx
@@ -3414,7 +3414,7 @@
           <a:p>
             <a:fld id="{37950DB5-2104-4786-82B8-B24E25A1AB8F}" type="datetimeFigureOut">
               <a:rPr lang="en-GB" smtClean="0"/>
-              <a:t>15/04/2026</a:t>
+              <a:t>05/08/2026</a:t>
             </a:fld>
             <a:endParaRPr lang="en-GB"/>
           </a:p>
@@ -3813,7 +3813,7 @@
           <a:p>
             <a:fld id="{9B2BDEDC-E2F2-4F04-950E-7CC102601F59}" type="datetime1">
               <a:rPr lang="en-GB" smtClean="0"/>
-              <a:t>15/04/2026</a:t>
+              <a:t>05/08/2026</a:t>
             </a:fld>
             <a:endParaRPr lang="en-GB"/>
           </a:p>
@@ -3983,7 +3983,7 @@
           <a:p>
             <a:fld id="{2E3E2EE1-C4D8-4BB2-9A76-2764ABF148D4}" type="datetime1">
               <a:rPr lang="en-GB" smtClean="0"/>
-              <a:t>15/04/2026</a:t>
+              <a:t>05/08/2026</a:t>
             </a:fld>
             <a:endParaRPr lang="en-GB"/>
           </a:p>
@@ -4163,7 +4163,7 @@
           <a:p>
             <a:fld id="{434872B2-883F-4D2B-887E-3B6D1390DAD7}" type="datetime1">
               <a:rPr lang="en-GB" smtClean="0"/>
-              <a:t>15/04/2026</a:t>
+              <a:t>05/08/2026</a:t>
             </a:fld>
             <a:endParaRPr lang="en-GB"/>
           </a:p>
@@ -4333,7 +4333,7 @@
           <a:p>
             <a:fld id="{783553C1-6954-4A34-B35F-A084FF96A446}" type="datetime1">
               <a:rPr lang="en-GB" smtClean="0"/>
-              <a:t>15/04/2026</a:t>
+              <a:t>05/08/2026</a:t>
             </a:fld>
             <a:endParaRPr lang="en-GB"/>
           </a:p>
@@ -4579,7 +4579,7 @@
           <a:p>
             <a:fld id="{01C149E3-5543-4B80-B951-CEB715655DEB}" type="datetime1">
               <a:rPr lang="en-GB" smtClean="0"/>
-              <a:t>15/04/2026</a:t>
+              <a:t>05/08/2026</a:t>
             </a:fld>
             <a:endParaRPr lang="en-GB"/>
           </a:p>
@@ -4811,7 +4811,7 @@
           <a:p>
             <a:fld id="{B7D493B2-834E-4862-AED9-B565B4392C72}" type="datetime1">
               <a:rPr lang="en-GB" smtClean="0"/>
-              <a:t>15/04/2026</a:t>
+              <a:t>05/08/2026</a:t>
             </a:fld>
             <a:endParaRPr lang="en-GB"/>
           </a:p>
@@ -5178,7 +5178,7 @@
           <a:p>
             <a:fld id="{6F9DDD9B-5FA7-4503-8C80-FB8030B1CE74}" type="datetime1">
               <a:rPr lang="en-GB" smtClean="0"/>
-              <a:t>15/04/2026</a:t>
+              <a:t>05/08/2026</a:t>
             </a:fld>
             <a:endParaRPr lang="en-GB"/>
           </a:p>
@@ -5296,7 +5296,7 @@
           <a:p>
             <a:fld id="{95D3AA76-C994-441E-801C-3B16D6753E8D}" type="datetime1">
               <a:rPr lang="en-GB" smtClean="0"/>
-              <a:t>15/04/2026</a:t>
+              <a:t>05/08/2026</a:t>
             </a:fld>
             <a:endParaRPr lang="en-GB"/>
           </a:p>
@@ -5391,7 +5391,7 @@
           <a:p>
             <a:fld id="{7010D2A5-42CA-4979-B793-53B90BAA3A34}" type="datetime1">
               <a:rPr lang="en-GB" smtClean="0"/>
-              <a:t>15/04/2026</a:t>
+              <a:t>05/08/2026</a:t>
             </a:fld>
             <a:endParaRPr lang="en-GB"/>
           </a:p>
@@ -5668,7 +5668,7 @@
           <a:p>
             <a:fld id="{5D916DA7-C8C2-4935-AF9B-A51302BE3A47}" type="datetime1">
               <a:rPr lang="en-GB" smtClean="0"/>
-              <a:t>15/04/2026</a:t>
+              <a:t>05/08/2026</a:t>
             </a:fld>
             <a:endParaRPr lang="en-GB"/>
           </a:p>
@@ -5925,7 +5925,7 @@
           <a:p>
             <a:fld id="{313DD15D-D807-4B24-B334-9F8F24B01B09}" type="datetime1">
               <a:rPr lang="en-GB" smtClean="0"/>
-              <a:t>15/04/2026</a:t>
+              <a:t>05/08/2026</a:t>
             </a:fld>
             <a:endParaRPr lang="en-GB"/>
           </a:p>
@@ -6138,7 +6138,7 @@
           <a:p>
             <a:fld id="{FA582E91-2573-494E-BD33-F6C267F95D3B}" type="datetime1">
               <a:rPr lang="en-GB" smtClean="0"/>
-              <a:t>15/04/2026</a:t>
+              <a:t>05/08/2026</a:t>
             </a:fld>
             <a:endParaRPr lang="en-GB"/>
           </a:p>
@@ -43311,7 +43311,7 @@
         </p:nvSpPr>
         <p:spPr>
           <a:xfrm>
-            <a:off x="471488" y="1478847"/>
+            <a:off x="539116" y="3687918"/>
             <a:ext cx="5915024" cy="4616648"/>
           </a:xfrm>
           <a:prstGeom prst="rect">

</xml_diff>